<commit_message>
updating presentation + adding some python regression scripts
</commit_message>
<xml_diff>
--- a/Tokosavorum_2.pptx
+++ b/Tokosavorum_2.pptx
@@ -17,11 +17,12 @@
     <p:sldId id="271" r:id="rId11"/>
     <p:sldId id="266" r:id="rId12"/>
     <p:sldId id="272" r:id="rId13"/>
-    <p:sldId id="267" r:id="rId14"/>
-    <p:sldId id="270" r:id="rId15"/>
-    <p:sldId id="265" r:id="rId16"/>
-    <p:sldId id="268" r:id="rId17"/>
-    <p:sldId id="263" r:id="rId18"/>
+    <p:sldId id="273" r:id="rId14"/>
+    <p:sldId id="267" r:id="rId15"/>
+    <p:sldId id="270" r:id="rId16"/>
+    <p:sldId id="265" r:id="rId17"/>
+    <p:sldId id="268" r:id="rId18"/>
+    <p:sldId id="263" r:id="rId19"/>
   </p:sldIdLst>
   <p:sldSz cx="12192000" cy="6858000"/>
   <p:notesSz cx="6858000" cy="9144000"/>
@@ -259,7 +260,7 @@
           <a:p>
             <a:fld id="{26B45A88-84CD-47B4-B068-1CCEBD78BFD4}" type="datetimeFigureOut">
               <a:rPr lang="ru-RU" smtClean="0"/>
-              <a:t>10.03.2026</a:t>
+              <a:t>11.03.2026</a:t>
             </a:fld>
             <a:endParaRPr lang="ru-RU"/>
           </a:p>
@@ -429,7 +430,7 @@
           <a:p>
             <a:fld id="{26B45A88-84CD-47B4-B068-1CCEBD78BFD4}" type="datetimeFigureOut">
               <a:rPr lang="ru-RU" smtClean="0"/>
-              <a:t>10.03.2026</a:t>
+              <a:t>11.03.2026</a:t>
             </a:fld>
             <a:endParaRPr lang="ru-RU"/>
           </a:p>
@@ -609,7 +610,7 @@
           <a:p>
             <a:fld id="{26B45A88-84CD-47B4-B068-1CCEBD78BFD4}" type="datetimeFigureOut">
               <a:rPr lang="ru-RU" smtClean="0"/>
-              <a:t>10.03.2026</a:t>
+              <a:t>11.03.2026</a:t>
             </a:fld>
             <a:endParaRPr lang="ru-RU"/>
           </a:p>
@@ -779,7 +780,7 @@
           <a:p>
             <a:fld id="{26B45A88-84CD-47B4-B068-1CCEBD78BFD4}" type="datetimeFigureOut">
               <a:rPr lang="ru-RU" smtClean="0"/>
-              <a:t>10.03.2026</a:t>
+              <a:t>11.03.2026</a:t>
             </a:fld>
             <a:endParaRPr lang="ru-RU"/>
           </a:p>
@@ -1025,7 +1026,7 @@
           <a:p>
             <a:fld id="{26B45A88-84CD-47B4-B068-1CCEBD78BFD4}" type="datetimeFigureOut">
               <a:rPr lang="ru-RU" smtClean="0"/>
-              <a:t>10.03.2026</a:t>
+              <a:t>11.03.2026</a:t>
             </a:fld>
             <a:endParaRPr lang="ru-RU"/>
           </a:p>
@@ -1257,7 +1258,7 @@
           <a:p>
             <a:fld id="{26B45A88-84CD-47B4-B068-1CCEBD78BFD4}" type="datetimeFigureOut">
               <a:rPr lang="ru-RU" smtClean="0"/>
-              <a:t>10.03.2026</a:t>
+              <a:t>11.03.2026</a:t>
             </a:fld>
             <a:endParaRPr lang="ru-RU"/>
           </a:p>
@@ -1624,7 +1625,7 @@
           <a:p>
             <a:fld id="{26B45A88-84CD-47B4-B068-1CCEBD78BFD4}" type="datetimeFigureOut">
               <a:rPr lang="ru-RU" smtClean="0"/>
-              <a:t>10.03.2026</a:t>
+              <a:t>11.03.2026</a:t>
             </a:fld>
             <a:endParaRPr lang="ru-RU"/>
           </a:p>
@@ -1742,7 +1743,7 @@
           <a:p>
             <a:fld id="{26B45A88-84CD-47B4-B068-1CCEBD78BFD4}" type="datetimeFigureOut">
               <a:rPr lang="ru-RU" smtClean="0"/>
-              <a:t>10.03.2026</a:t>
+              <a:t>11.03.2026</a:t>
             </a:fld>
             <a:endParaRPr lang="ru-RU"/>
           </a:p>
@@ -1837,7 +1838,7 @@
           <a:p>
             <a:fld id="{26B45A88-84CD-47B4-B068-1CCEBD78BFD4}" type="datetimeFigureOut">
               <a:rPr lang="ru-RU" smtClean="0"/>
-              <a:t>10.03.2026</a:t>
+              <a:t>11.03.2026</a:t>
             </a:fld>
             <a:endParaRPr lang="ru-RU"/>
           </a:p>
@@ -2114,7 +2115,7 @@
           <a:p>
             <a:fld id="{26B45A88-84CD-47B4-B068-1CCEBD78BFD4}" type="datetimeFigureOut">
               <a:rPr lang="ru-RU" smtClean="0"/>
-              <a:t>10.03.2026</a:t>
+              <a:t>11.03.2026</a:t>
             </a:fld>
             <a:endParaRPr lang="ru-RU"/>
           </a:p>
@@ -2367,7 +2368,7 @@
           <a:p>
             <a:fld id="{26B45A88-84CD-47B4-B068-1CCEBD78BFD4}" type="datetimeFigureOut">
               <a:rPr lang="ru-RU" smtClean="0"/>
-              <a:t>10.03.2026</a:t>
+              <a:t>11.03.2026</a:t>
             </a:fld>
             <a:endParaRPr lang="ru-RU"/>
           </a:p>
@@ -2580,7 +2581,7 @@
           <a:p>
             <a:fld id="{26B45A88-84CD-47B4-B068-1CCEBD78BFD4}" type="datetimeFigureOut">
               <a:rPr lang="ru-RU" smtClean="0"/>
-              <a:t>10.03.2026</a:t>
+              <a:t>11.03.2026</a:t>
             </a:fld>
             <a:endParaRPr lang="ru-RU"/>
           </a:p>
@@ -3335,8 +3336,8 @@
           </a:p>
         </p:txBody>
       </p:sp>
-      <mc:AlternateContent xmlns:mc="http://schemas.openxmlformats.org/markup-compatibility/2006">
-        <mc:Choice xmlns:a14="http://schemas.microsoft.com/office/drawing/2010/main" Requires="a14">
+      <mc:AlternateContent xmlns:mc="http://schemas.openxmlformats.org/markup-compatibility/2006" xmlns:a14="http://schemas.microsoft.com/office/drawing/2010/main">
+        <mc:Choice Requires="a14">
           <p:sp>
             <p:nvSpPr>
               <p:cNvPr id="3" name="Content Placeholder 2"/>
@@ -3635,7 +3636,7 @@
             </p:txBody>
           </p:sp>
         </mc:Choice>
-        <mc:Fallback>
+        <mc:Fallback xmlns="">
           <p:sp>
             <p:nvSpPr>
               <p:cNvPr id="3" name="Content Placeholder 2"/>
@@ -3673,8 +3674,8 @@
           </p:sp>
         </mc:Fallback>
       </mc:AlternateContent>
-      <mc:AlternateContent xmlns:mc="http://schemas.openxmlformats.org/markup-compatibility/2006">
-        <mc:Choice xmlns:a14="http://schemas.microsoft.com/office/drawing/2010/main" Requires="a14">
+      <mc:AlternateContent xmlns:mc="http://schemas.openxmlformats.org/markup-compatibility/2006" xmlns:a14="http://schemas.microsoft.com/office/drawing/2010/main">
+        <mc:Choice Requires="a14">
           <p:sp>
             <p:nvSpPr>
               <p:cNvPr id="6" name="TextBox 5"/>
@@ -3809,7 +3810,7 @@
             </p:txBody>
           </p:sp>
         </mc:Choice>
-        <mc:Fallback>
+        <mc:Fallback xmlns="">
           <p:sp>
             <p:nvSpPr>
               <p:cNvPr id="6" name="TextBox 5"/>
@@ -3848,8 +3849,8 @@
           </p:sp>
         </mc:Fallback>
       </mc:AlternateContent>
-      <mc:AlternateContent xmlns:mc="http://schemas.openxmlformats.org/markup-compatibility/2006">
-        <mc:Choice xmlns:a14="http://schemas.microsoft.com/office/drawing/2010/main" Requires="a14">
+      <mc:AlternateContent xmlns:mc="http://schemas.openxmlformats.org/markup-compatibility/2006" xmlns:a14="http://schemas.microsoft.com/office/drawing/2010/main">
+        <mc:Choice Requires="a14">
           <p:sp>
             <p:nvSpPr>
               <p:cNvPr id="8" name="TextBox 7"/>
@@ -3982,7 +3983,7 @@
             </p:txBody>
           </p:sp>
         </mc:Choice>
-        <mc:Fallback>
+        <mc:Fallback xmlns="">
           <p:sp>
             <p:nvSpPr>
               <p:cNvPr id="8" name="TextBox 7"/>
@@ -4106,6 +4107,66 @@
 </file>
 
 <file path=ppt/slides/slide13.xml><?xml version="1.0" encoding="utf-8"?>
+<p:sld xmlns:a="http://schemas.openxmlformats.org/drawingml/2006/main" xmlns:r="http://schemas.openxmlformats.org/officeDocument/2006/relationships" xmlns:p="http://schemas.openxmlformats.org/presentationml/2006/main">
+  <p:cSld>
+    <p:spTree>
+      <p:nvGrpSpPr>
+        <p:cNvPr id="1" name=""/>
+        <p:cNvGrpSpPr/>
+        <p:nvPr/>
+      </p:nvGrpSpPr>
+      <p:grpSpPr>
+        <a:xfrm>
+          <a:off x="0" y="0"/>
+          <a:ext cx="0" cy="0"/>
+          <a:chOff x="0" y="0"/>
+          <a:chExt cx="0" cy="0"/>
+        </a:xfrm>
+      </p:grpSpPr>
+      <p:pic>
+        <p:nvPicPr>
+          <p:cNvPr id="5" name="Picture 4"/>
+          <p:cNvPicPr>
+            <a:picLocks noChangeAspect="1"/>
+          </p:cNvPicPr>
+          <p:nvPr/>
+        </p:nvPicPr>
+        <p:blipFill>
+          <a:blip r:embed="rId2">
+            <a:extLst>
+              <a:ext uri="{28A0092B-C50C-407E-A947-70E740481C1C}">
+                <a14:useLocalDpi xmlns:a14="http://schemas.microsoft.com/office/drawing/2010/main" val="0"/>
+              </a:ext>
+            </a:extLst>
+          </a:blip>
+          <a:stretch>
+            <a:fillRect/>
+          </a:stretch>
+        </p:blipFill>
+        <p:spPr>
+          <a:xfrm>
+            <a:off x="1251750" y="0"/>
+            <a:ext cx="9144000" cy="6858000"/>
+          </a:xfrm>
+          <a:prstGeom prst="rect">
+            <a:avLst/>
+          </a:prstGeom>
+        </p:spPr>
+      </p:pic>
+    </p:spTree>
+    <p:extLst>
+      <p:ext uri="{BB962C8B-B14F-4D97-AF65-F5344CB8AC3E}">
+        <p14:creationId xmlns:p14="http://schemas.microsoft.com/office/powerpoint/2010/main" val="2752982984"/>
+      </p:ext>
+    </p:extLst>
+  </p:cSld>
+  <p:clrMapOvr>
+    <a:masterClrMapping/>
+  </p:clrMapOvr>
+</p:sld>
+</file>
+
+<file path=ppt/slides/slide14.xml><?xml version="1.0" encoding="utf-8"?>
 <p:sld xmlns:a="http://schemas.openxmlformats.org/drawingml/2006/main" xmlns:r="http://schemas.openxmlformats.org/officeDocument/2006/relationships" xmlns:p="http://schemas.openxmlformats.org/presentationml/2006/main">
   <p:cSld>
     <p:spTree>
@@ -4319,7 +4380,7 @@
 </p:sld>
 </file>
 
-<file path=ppt/slides/slide14.xml><?xml version="1.0" encoding="utf-8"?>
+<file path=ppt/slides/slide15.xml><?xml version="1.0" encoding="utf-8"?>
 <p:sld xmlns:a="http://schemas.openxmlformats.org/drawingml/2006/main" xmlns:r="http://schemas.openxmlformats.org/officeDocument/2006/relationships" xmlns:p="http://schemas.openxmlformats.org/presentationml/2006/main">
   <p:cSld>
     <p:spTree>
@@ -4563,7 +4624,7 @@
 </p:sld>
 </file>
 
-<file path=ppt/slides/slide15.xml><?xml version="1.0" encoding="utf-8"?>
+<file path=ppt/slides/slide16.xml><?xml version="1.0" encoding="utf-8"?>
 <p:sld xmlns:a="http://schemas.openxmlformats.org/drawingml/2006/main" xmlns:r="http://schemas.openxmlformats.org/officeDocument/2006/relationships" xmlns:p="http://schemas.openxmlformats.org/presentationml/2006/main">
   <p:cSld>
     <p:spTree>
@@ -4753,7 +4814,7 @@
 </p:sld>
 </file>
 
-<file path=ppt/slides/slide16.xml><?xml version="1.0" encoding="utf-8"?>
+<file path=ppt/slides/slide17.xml><?xml version="1.0" encoding="utf-8"?>
 <p:sld xmlns:a="http://schemas.openxmlformats.org/drawingml/2006/main" xmlns:r="http://schemas.openxmlformats.org/officeDocument/2006/relationships" xmlns:p="http://schemas.openxmlformats.org/presentationml/2006/main">
   <p:cSld>
     <p:spTree>
@@ -4805,7 +4866,7 @@
       </p:sp>
       <p:pic>
         <p:nvPicPr>
-          <p:cNvPr id="5" name="Picture 4"/>
+          <p:cNvPr id="3" name="Picture 2"/>
           <p:cNvPicPr>
             <a:picLocks noChangeAspect="1"/>
           </p:cNvPicPr>
@@ -4819,8 +4880,8 @@
         </p:blipFill>
         <p:spPr>
           <a:xfrm>
-            <a:off x="148403" y="2710429"/>
-            <a:ext cx="11809818" cy="1577965"/>
+            <a:off x="146670" y="2591554"/>
+            <a:ext cx="11813284" cy="1556790"/>
           </a:xfrm>
           <a:prstGeom prst="rect">
             <a:avLst/>
@@ -4840,7 +4901,7 @@
 </p:sld>
 </file>
 
-<file path=ppt/slides/slide17.xml><?xml version="1.0" encoding="utf-8"?>
+<file path=ppt/slides/slide18.xml><?xml version="1.0" encoding="utf-8"?>
 <p:sld xmlns:a="http://schemas.openxmlformats.org/drawingml/2006/main" xmlns:r="http://schemas.openxmlformats.org/officeDocument/2006/relationships" xmlns:p="http://schemas.openxmlformats.org/presentationml/2006/main">
   <p:cSld>
     <p:spTree>

</xml_diff>